<commit_message>
docs: atuliza slides e README
</commit_message>
<xml_diff>
--- a/slides/Cleber_Guilherme_ORI_metricas.pptx
+++ b/slides/Cleber_Guilherme_ORI_metricas.pptx
@@ -25,6 +25,10 @@
     <p:embeddedFont>
       <p:font typeface="Calibri (MS)" charset="1" panose="020F0502020204030204"/>
       <p:regular r:id="rId16"/>
+    </p:embeddedFont>
+    <p:embeddedFont>
+      <p:font typeface="Arimo" charset="1" panose="020B0604020202020204"/>
+      <p:regular r:id="rId17"/>
     </p:embeddedFont>
   </p:embeddedFontLst>
   <p:defaultTextStyle>
@@ -4106,7 +4110,7 @@
         <p:spPr>
           <a:xfrm rot="0">
             <a:off x="1189577" y="7959595"/>
-            <a:ext cx="7504081" cy="1328861"/>
+            <a:ext cx="7504081" cy="638175"/>
           </a:xfrm>
           <a:prstGeom prst="rect">
             <a:avLst/>
@@ -4133,7 +4137,7 @@
                 <a:cs typeface="Calibri (MS)"/>
                 <a:sym typeface="Calibri (MS)"/>
               </a:rPr>
-              <a:t>WSL2 (Windows 11): Max ~3.202 a 5.700 IOPS | Picos de Latência evidentes</a:t>
+              <a:t>WSL2 (Windows 11): Max ~3.202 a 6.585 IOPS | Picos de Latência evidentes</a:t>
             </a:r>
           </a:p>
         </p:txBody>
@@ -4729,8 +4733,8 @@
         </p:nvSpPr>
         <p:spPr>
           <a:xfrm rot="0">
-            <a:off x="1189577" y="566214"/>
-            <a:ext cx="15877384" cy="1309811"/>
+            <a:off x="1189577" y="1964667"/>
+            <a:ext cx="14419642" cy="6310040"/>
           </a:xfrm>
           <a:prstGeom prst="rect">
             <a:avLst/>
@@ -4742,41 +4746,375 @@
           </a:bodyPr>
           <a:lstStyle/>
           <a:p>
-            <a:pPr algn="l">
-              <a:lnSpc>
-                <a:spcPts val="1981"/>
-              </a:lnSpc>
-            </a:pPr>
-            <a:r>
-              <a:rPr lang="en-US" sz="1651" b="true">
-                <a:solidFill>
-                  <a:srgbClr val="06B6D4"/>
-                </a:solidFill>
-                <a:latin typeface="Calibri (MS) Bold"/>
-                <a:ea typeface="Calibri (MS) Bold"/>
-                <a:cs typeface="Calibri (MS) Bold"/>
-                <a:sym typeface="Calibri (MS) Bold"/>
-              </a:rPr>
-              <a:t>SISTEMAS DE DISCO</a:t>
-            </a:r>
-          </a:p>
-          <a:p>
-            <a:pPr algn="l">
-              <a:lnSpc>
-                <a:spcPts val="4323"/>
-              </a:lnSpc>
-            </a:pPr>
-            <a:r>
-              <a:rPr lang="en-US" sz="3602" b="true">
-                <a:solidFill>
-                  <a:srgbClr val="F8FAFC"/>
-                </a:solidFill>
-                <a:latin typeface="Calibri (MS) Bold"/>
-                <a:ea typeface="Calibri (MS) Bold"/>
-                <a:cs typeface="Calibri (MS) Bold"/>
-                <a:sym typeface="Calibri (MS) Bold"/>
-              </a:rPr>
-              <a:t>Exercício 2 – Memória Externa (Fórmula de Acesso)</a:t>
+            <a:pPr algn="just">
+              <a:lnSpc>
+                <a:spcPts val="2759"/>
+              </a:lnSpc>
+              <a:spcBef>
+                <a:spcPct val="0"/>
+              </a:spcBef>
+            </a:pPr>
+            <a:r>
+              <a:rPr lang="en-US" sz="2299">
+                <a:solidFill>
+                  <a:srgbClr val="FFFFFF"/>
+                </a:solidFill>
+                <a:latin typeface="Calibri (MS)"/>
+                <a:ea typeface="Calibri (MS)"/>
+                <a:cs typeface="Calibri (MS)"/>
+                <a:sym typeface="Calibri (MS)"/>
+              </a:rPr>
+              <a:t>wsl</a:t>
+            </a:r>
+          </a:p>
+          <a:p>
+            <a:pPr algn="just">
+              <a:lnSpc>
+                <a:spcPts val="2759"/>
+              </a:lnSpc>
+              <a:spcBef>
+                <a:spcPct val="0"/>
+              </a:spcBef>
+            </a:pPr>
+            <a:r>
+              <a:rPr lang="en-US" sz="2299">
+                <a:solidFill>
+                  <a:srgbClr val="FFFFFF"/>
+                </a:solidFill>
+                <a:latin typeface="Calibri (MS)"/>
+                <a:ea typeface="Calibri (MS)"/>
+                <a:cs typeface="Calibri (MS)"/>
+                <a:sym typeface="Calibri (MS)"/>
+              </a:rPr>
+              <a:t>cd ~</a:t>
+            </a:r>
+          </a:p>
+          <a:p>
+            <a:pPr algn="just">
+              <a:lnSpc>
+                <a:spcPts val="2759"/>
+              </a:lnSpc>
+              <a:spcBef>
+                <a:spcPct val="0"/>
+              </a:spcBef>
+            </a:pPr>
+            <a:r>
+              <a:rPr lang="en-US" sz="2299">
+                <a:solidFill>
+                  <a:srgbClr val="FFFFFF"/>
+                </a:solidFill>
+                <a:latin typeface="Calibri (MS)"/>
+                <a:ea typeface="Calibri (MS)"/>
+                <a:cs typeface="Calibri (MS)"/>
+                <a:sym typeface="Calibri (MS)"/>
+              </a:rPr>
+              <a:t>sudo apt update</a:t>
+            </a:r>
+          </a:p>
+          <a:p>
+            <a:pPr algn="just">
+              <a:lnSpc>
+                <a:spcPts val="2759"/>
+              </a:lnSpc>
+              <a:spcBef>
+                <a:spcPct val="0"/>
+              </a:spcBef>
+            </a:pPr>
+            <a:r>
+              <a:rPr lang="en-US" sz="2299">
+                <a:solidFill>
+                  <a:srgbClr val="FFFFFF"/>
+                </a:solidFill>
+                <a:latin typeface="Calibri (MS)"/>
+                <a:ea typeface="Calibri (MS)"/>
+                <a:cs typeface="Calibri (MS)"/>
+                <a:sym typeface="Calibri (MS)"/>
+              </a:rPr>
+              <a:t>sudo apt install -y fio zlib1g-dev libjpeg-dev python3-pip python3-venv git</a:t>
+            </a:r>
+          </a:p>
+          <a:p>
+            <a:pPr algn="just">
+              <a:lnSpc>
+                <a:spcPts val="2759"/>
+              </a:lnSpc>
+              <a:spcBef>
+                <a:spcPct val="0"/>
+              </a:spcBef>
+            </a:pPr>
+            <a:r>
+              <a:rPr lang="en-US" sz="2299">
+                <a:solidFill>
+                  <a:srgbClr val="FFFFFF"/>
+                </a:solidFill>
+                <a:latin typeface="Calibri (MS)"/>
+                <a:ea typeface="Calibri (MS)"/>
+                <a:cs typeface="Calibri (MS)"/>
+                <a:sym typeface="Calibri (MS)"/>
+              </a:rPr>
+              <a:t>rm -rf fio-plot</a:t>
+            </a:r>
+          </a:p>
+          <a:p>
+            <a:pPr algn="just">
+              <a:lnSpc>
+                <a:spcPts val="2759"/>
+              </a:lnSpc>
+              <a:spcBef>
+                <a:spcPct val="0"/>
+              </a:spcBef>
+            </a:pPr>
+            <a:r>
+              <a:rPr lang="en-US" sz="2299">
+                <a:solidFill>
+                  <a:srgbClr val="FFFFFF"/>
+                </a:solidFill>
+                <a:latin typeface="Calibri (MS)"/>
+                <a:ea typeface="Calibri (MS)"/>
+                <a:cs typeface="Calibri (MS)"/>
+                <a:sym typeface="Calibri (MS)"/>
+              </a:rPr>
+              <a:t>git clone https://github.com/louwrentius/fio-plot.git</a:t>
+            </a:r>
+          </a:p>
+          <a:p>
+            <a:pPr algn="just">
+              <a:lnSpc>
+                <a:spcPts val="2759"/>
+              </a:lnSpc>
+              <a:spcBef>
+                <a:spcPct val="0"/>
+              </a:spcBef>
+            </a:pPr>
+            <a:r>
+              <a:rPr lang="en-US" sz="2299">
+                <a:solidFill>
+                  <a:srgbClr val="FFFFFF"/>
+                </a:solidFill>
+                <a:latin typeface="Calibri (MS)"/>
+                <a:ea typeface="Calibri (MS)"/>
+                <a:cs typeface="Calibri (MS)"/>
+                <a:sym typeface="Calibri (MS)"/>
+              </a:rPr>
+              <a:t>cd fio-plot</a:t>
+            </a:r>
+          </a:p>
+          <a:p>
+            <a:pPr algn="just">
+              <a:lnSpc>
+                <a:spcPts val="2759"/>
+              </a:lnSpc>
+              <a:spcBef>
+                <a:spcPct val="0"/>
+              </a:spcBef>
+            </a:pPr>
+          </a:p>
+          <a:p>
+            <a:pPr algn="just">
+              <a:lnSpc>
+                <a:spcPts val="2759"/>
+              </a:lnSpc>
+              <a:spcBef>
+                <a:spcPct val="0"/>
+              </a:spcBef>
+            </a:pPr>
+            <a:r>
+              <a:rPr lang="en-US" sz="2299">
+                <a:solidFill>
+                  <a:srgbClr val="FFFFFF"/>
+                </a:solidFill>
+                <a:latin typeface="Calibri (MS)"/>
+                <a:ea typeface="Calibri (MS)"/>
+                <a:cs typeface="Calibri (MS)"/>
+                <a:sym typeface="Calibri (MS)"/>
+              </a:rPr>
+              <a:t>python3 -m venv venv</a:t>
+            </a:r>
+          </a:p>
+          <a:p>
+            <a:pPr algn="just">
+              <a:lnSpc>
+                <a:spcPts val="2759"/>
+              </a:lnSpc>
+              <a:spcBef>
+                <a:spcPct val="0"/>
+              </a:spcBef>
+            </a:pPr>
+            <a:r>
+              <a:rPr lang="en-US" sz="2299">
+                <a:solidFill>
+                  <a:srgbClr val="FFFFFF"/>
+                </a:solidFill>
+                <a:latin typeface="Calibri (MS)"/>
+                <a:ea typeface="Calibri (MS)"/>
+                <a:cs typeface="Calibri (MS)"/>
+                <a:sym typeface="Calibri (MS)"/>
+              </a:rPr>
+              <a:t>source venv/bin/activate</a:t>
+            </a:r>
+          </a:p>
+          <a:p>
+            <a:pPr algn="just">
+              <a:lnSpc>
+                <a:spcPts val="2759"/>
+              </a:lnSpc>
+              <a:spcBef>
+                <a:spcPct val="0"/>
+              </a:spcBef>
+            </a:pPr>
+            <a:r>
+              <a:rPr lang="en-US" sz="2299">
+                <a:solidFill>
+                  <a:srgbClr val="FFFFFF"/>
+                </a:solidFill>
+                <a:latin typeface="Calibri (MS)"/>
+                <a:ea typeface="Calibri (MS)"/>
+                <a:cs typeface="Calibri (MS)"/>
+                <a:sym typeface="Calibri (MS)"/>
+              </a:rPr>
+              <a:t>pip install fio-plot</a:t>
+            </a:r>
+          </a:p>
+          <a:p>
+            <a:pPr algn="just">
+              <a:lnSpc>
+                <a:spcPts val="2759"/>
+              </a:lnSpc>
+              <a:spcBef>
+                <a:spcPct val="0"/>
+              </a:spcBef>
+            </a:pPr>
+            <a:r>
+              <a:rPr lang="en-US" sz="2299">
+                <a:solidFill>
+                  <a:srgbClr val="FFFFFF"/>
+                </a:solidFill>
+                <a:latin typeface="Calibri (MS)"/>
+                <a:ea typeface="Calibri (MS)"/>
+                <a:cs typeface="Calibri (MS)"/>
+                <a:sym typeface="Calibri (MS)"/>
+              </a:rPr>
+              <a:t>mkdir -p /mnt/c/temp</a:t>
+            </a:r>
+          </a:p>
+          <a:p>
+            <a:pPr algn="just">
+              <a:lnSpc>
+                <a:spcPts val="2759"/>
+              </a:lnSpc>
+              <a:spcBef>
+                <a:spcPct val="0"/>
+              </a:spcBef>
+            </a:pPr>
+          </a:p>
+          <a:p>
+            <a:pPr algn="just">
+              <a:lnSpc>
+                <a:spcPts val="2759"/>
+              </a:lnSpc>
+              <a:spcBef>
+                <a:spcPct val="0"/>
+              </a:spcBef>
+            </a:pPr>
+            <a:r>
+              <a:rPr lang="en-US" sz="2299">
+                <a:solidFill>
+                  <a:srgbClr val="FFFFFF"/>
+                </a:solidFill>
+                <a:latin typeface="Calibri (MS)"/>
+                <a:ea typeface="Calibri (MS)"/>
+                <a:cs typeface="Calibri (MS)"/>
+                <a:sym typeface="Calibri (MS)"/>
+              </a:rPr>
+              <a:t>bench-fio --target /mnt/c/temp --type directory --size 2G --mode randread --output MeuPC --iodepth 1 8 32 --numjobs 1 4</a:t>
+            </a:r>
+          </a:p>
+          <a:p>
+            <a:pPr algn="just">
+              <a:lnSpc>
+                <a:spcPts val="2759"/>
+              </a:lnSpc>
+              <a:spcBef>
+                <a:spcPct val="0"/>
+              </a:spcBef>
+            </a:pPr>
+            <a:r>
+              <a:rPr lang="en-US" sz="2299">
+                <a:solidFill>
+                  <a:srgbClr val="FFFFFF"/>
+                </a:solidFill>
+                <a:latin typeface="Calibri (MS)"/>
+                <a:ea typeface="Calibri (MS)"/>
+                <a:cs typeface="Calibri (MS)"/>
+                <a:sym typeface="Calibri (MS)"/>
+              </a:rPr>
+              <a:t>fio-plot -i MeuPC/temp/4k/ -T "Performance de Leitura - Kingston SNV2S" -l -r randread -d 1 8 32 -n 1</a:t>
+            </a:r>
+          </a:p>
+          <a:p>
+            <a:pPr algn="just">
+              <a:lnSpc>
+                <a:spcPts val="2759"/>
+              </a:lnSpc>
+              <a:spcBef>
+                <a:spcPct val="0"/>
+              </a:spcBef>
+            </a:pPr>
+            <a:r>
+              <a:rPr lang="en-US" sz="2299">
+                <a:solidFill>
+                  <a:srgbClr val="FFFFFF"/>
+                </a:solidFill>
+                <a:latin typeface="Calibri (MS)"/>
+                <a:ea typeface="Calibri (MS)"/>
+                <a:cs typeface="Calibri (MS)"/>
+                <a:sym typeface="Calibri (MS)"/>
+              </a:rPr>
+              <a:t>fio-plot -i MeuPC/temp/4k/ -T "IOPS vs Latencia (Agrupado) - Kingston SNV2S" -l -r randread -d 1 8 32 -n 1 --group-bars</a:t>
+            </a:r>
+          </a:p>
+          <a:p>
+            <a:pPr algn="just">
+              <a:lnSpc>
+                <a:spcPts val="2759"/>
+              </a:lnSpc>
+              <a:spcBef>
+                <a:spcPct val="0"/>
+              </a:spcBef>
+            </a:pPr>
+            <a:r>
+              <a:rPr lang="en-US" sz="2299">
+                <a:solidFill>
+                  <a:srgbClr val="FFFFFF"/>
+                </a:solidFill>
+                <a:latin typeface="Calibri (MS)"/>
+                <a:ea typeface="Calibri (MS)"/>
+                <a:cs typeface="Calibri (MS)"/>
+                <a:sym typeface="Calibri (MS)"/>
+              </a:rPr>
+              <a:t>fio-plot -i MeuPC/temp/4k/ -T "Latencia 3D - Kingston SNV2S" -L -t lat -r randread -d 1 8 32 -n 1 4</a:t>
+            </a:r>
+          </a:p>
+          <a:p>
+            <a:pPr algn="just">
+              <a:lnSpc>
+                <a:spcPts val="2759"/>
+              </a:lnSpc>
+              <a:spcBef>
+                <a:spcPct val="0"/>
+              </a:spcBef>
+            </a:pPr>
+            <a:r>
+              <a:rPr lang="en-US" sz="2299">
+                <a:solidFill>
+                  <a:srgbClr val="FFFFFF"/>
+                </a:solidFill>
+                <a:latin typeface="Calibri (MS)"/>
+                <a:ea typeface="Calibri (MS)"/>
+                <a:cs typeface="Calibri (MS)"/>
+                <a:sym typeface="Calibri (MS)"/>
+              </a:rPr>
+              <a:t>explorer.exe .</a:t>
             </a:r>
           </a:p>
         </p:txBody>
@@ -4789,8 +5127,8 @@
         </p:nvSpPr>
         <p:spPr>
           <a:xfrm rot="0">
-            <a:off x="1189577" y="2203894"/>
-            <a:ext cx="15877384" cy="6810023"/>
+            <a:off x="1189577" y="566214"/>
+            <a:ext cx="15877384" cy="819150"/>
           </a:xfrm>
           <a:prstGeom prst="rect">
             <a:avLst/>
@@ -4804,18 +5142,11 @@
           <a:p>
             <a:pPr algn="l">
               <a:lnSpc>
-                <a:spcPts val="2882"/>
-              </a:lnSpc>
-            </a:pPr>
-          </a:p>
-          <a:p>
-            <a:pPr algn="l">
-              <a:lnSpc>
-                <a:spcPts val="2882"/>
-              </a:lnSpc>
-            </a:pPr>
-            <a:r>
-              <a:rPr lang="en-US" sz="2401" b="true">
+                <a:spcPts val="1981"/>
+              </a:lnSpc>
+            </a:pPr>
+            <a:r>
+              <a:rPr lang="en-US" sz="1651" b="true">
                 <a:solidFill>
                   <a:srgbClr val="06B6D4"/>
                 </a:solidFill>
@@ -4824,150 +5155,26 @@
                 <a:cs typeface="Calibri (MS) Bold"/>
                 <a:sym typeface="Calibri (MS) Bold"/>
               </a:rPr>
-              <a:t>Fórmula de Tempo de Acesso (tA):</a:t>
-            </a:r>
-            <a:r>
-              <a:rPr lang="en-US" sz="2401">
+              <a:t>CÓDIGO FONTE</a:t>
+            </a:r>
+          </a:p>
+          <a:p>
+            <a:pPr algn="l">
+              <a:lnSpc>
+                <a:spcPts val="4323"/>
+              </a:lnSpc>
+            </a:pPr>
+            <a:r>
+              <a:rPr lang="en-US" sz="3602" b="true">
                 <a:solidFill>
                   <a:srgbClr val="F8FAFC"/>
-                </a:solidFill>
-                <a:latin typeface="Calibri (MS)"/>
-                <a:ea typeface="Calibri (MS)"/>
-                <a:cs typeface="Calibri (MS)"/>
-                <a:sym typeface="Calibri (MS)"/>
-              </a:rPr>
-              <a:t> O tempo total de acesso a um setor é a soma de três componentes principais:</a:t>
-            </a:r>
-          </a:p>
-          <a:p>
-            <a:pPr algn="l">
-              <a:lnSpc>
-                <a:spcPts val="2882"/>
-              </a:lnSpc>
-            </a:pPr>
-            <a:r>
-              <a:rPr lang="en-US" sz="2401" b="true">
-                <a:solidFill>
-                  <a:srgbClr val="06B6D4"/>
                 </a:solidFill>
                 <a:latin typeface="Calibri (MS) Bold"/>
                 <a:ea typeface="Calibri (MS) Bold"/>
                 <a:cs typeface="Calibri (MS) Bold"/>
                 <a:sym typeface="Calibri (MS) Bold"/>
               </a:rPr>
-              <a:t>1. Tempo de Seek (ts):</a:t>
-            </a:r>
-            <a:r>
-              <a:rPr lang="en-US" sz="2401">
-                <a:solidFill>
-                  <a:srgbClr val="F8FAFC"/>
-                </a:solidFill>
-                <a:latin typeface="Calibri (MS)"/>
-                <a:ea typeface="Calibri (MS)"/>
-                <a:cs typeface="Calibri (MS)"/>
-                <a:sym typeface="Calibri (MS)"/>
-              </a:rPr>
-              <a:t> Tempo médio para posicionar a cabeça sobre a trilha desejada.</a:t>
-            </a:r>
-          </a:p>
-          <a:p>
-            <a:pPr algn="l">
-              <a:lnSpc>
-                <a:spcPts val="2882"/>
-              </a:lnSpc>
-            </a:pPr>
-            <a:r>
-              <a:rPr lang="en-US" sz="2401" b="true">
-                <a:solidFill>
-                  <a:srgbClr val="06B6D4"/>
-                </a:solidFill>
-                <a:latin typeface="Calibri (MS) Bold"/>
-                <a:ea typeface="Calibri (MS) Bold"/>
-                <a:cs typeface="Calibri (MS) Bold"/>
-                <a:sym typeface="Calibri (MS) Bold"/>
-              </a:rPr>
-              <a:t>2. Latência Rotacional:</a:t>
-            </a:r>
-            <a:r>
-              <a:rPr lang="en-US" sz="2401">
-                <a:solidFill>
-                  <a:srgbClr val="F8FAFC"/>
-                </a:solidFill>
-                <a:latin typeface="Calibri (MS)"/>
-                <a:ea typeface="Calibri (MS)"/>
-                <a:cs typeface="Calibri (MS)"/>
-                <a:sym typeface="Calibri (MS)"/>
-              </a:rPr>
-              <a:t> Tempo médio para o setor chegar até a cabeça de leitura. Equivale a meia rotação: 1 / (2r).</a:t>
-            </a:r>
-          </a:p>
-          <a:p>
-            <a:pPr algn="l">
-              <a:lnSpc>
-                <a:spcPts val="2882"/>
-              </a:lnSpc>
-            </a:pPr>
-            <a:r>
-              <a:rPr lang="en-US" sz="2401" b="true">
-                <a:solidFill>
-                  <a:srgbClr val="06B6D4"/>
-                </a:solidFill>
-                <a:latin typeface="Calibri (MS) Bold"/>
-                <a:ea typeface="Calibri (MS) Bold"/>
-                <a:cs typeface="Calibri (MS) Bold"/>
-                <a:sym typeface="Calibri (MS) Bold"/>
-              </a:rPr>
-              <a:t>3. Tempo de Transferência:</a:t>
-            </a:r>
-            <a:r>
-              <a:rPr lang="en-US" sz="2401">
-                <a:solidFill>
-                  <a:srgbClr val="F8FAFC"/>
-                </a:solidFill>
-                <a:latin typeface="Calibri (MS)"/>
-                <a:ea typeface="Calibri (MS)"/>
-                <a:cs typeface="Calibri (MS)"/>
-                <a:sym typeface="Calibri (MS)"/>
-              </a:rPr>
-              <a:t> Tempo para ler os n bits do setor. Como a trilha tem N bits e uma rotação demora 1/r, o tempo é n / (r * N).</a:t>
-            </a:r>
-          </a:p>
-          <a:p>
-            <a:pPr algn="l">
-              <a:lnSpc>
-                <a:spcPts val="2882"/>
-              </a:lnSpc>
-            </a:pPr>
-            <a:r>
-              <a:rPr lang="en-US" sz="2401" b="true">
-                <a:solidFill>
-                  <a:srgbClr val="06B6D4"/>
-                </a:solidFill>
-                <a:latin typeface="Calibri (MS) Bold"/>
-                <a:ea typeface="Calibri (MS) Bold"/>
-                <a:cs typeface="Calibri (MS) Bold"/>
-                <a:sym typeface="Calibri (MS) Bold"/>
-              </a:rPr>
-              <a:t>Resultado Final:</a:t>
-            </a:r>
-          </a:p>
-          <a:p>
-            <a:pPr algn="ctr">
-              <a:lnSpc>
-                <a:spcPts val="5043"/>
-              </a:lnSpc>
-            </a:pPr>
-            <a:r>
-              <a:rPr lang="en-US" sz="4203" b="true">
-                <a:solidFill>
-                  <a:srgbClr val="F8FAFC"/>
-                </a:solidFill>
-                <a:latin typeface="Calibri (MS) Bold"/>
-                <a:ea typeface="Calibri (MS) Bold"/>
-                <a:cs typeface="Calibri (MS) Bold"/>
-                <a:sym typeface="Calibri (MS) Bold"/>
-              </a:rPr>
-              <a:t>tA = ts + 1/(2r) + n/(rN)</a:t>
+              <a:t>Código utilizado no Windows</a:t>
             </a:r>
           </a:p>
         </p:txBody>
@@ -5012,8 +5219,8 @@
         </p:nvSpPr>
         <p:spPr>
           <a:xfrm rot="0">
-            <a:off x="1189577" y="566214"/>
-            <a:ext cx="15877384" cy="1309811"/>
+            <a:off x="1189577" y="2181225"/>
+            <a:ext cx="14034929" cy="5876925"/>
           </a:xfrm>
           <a:prstGeom prst="rect">
             <a:avLst/>
@@ -5027,39 +5234,339 @@
           <a:p>
             <a:pPr algn="l">
               <a:lnSpc>
-                <a:spcPts val="1981"/>
-              </a:lnSpc>
-            </a:pPr>
-            <a:r>
-              <a:rPr lang="en-US" sz="1651" b="true">
-                <a:solidFill>
-                  <a:srgbClr val="06B6D4"/>
-                </a:solidFill>
-                <a:latin typeface="Calibri (MS) Bold"/>
-                <a:ea typeface="Calibri (MS) Bold"/>
-                <a:cs typeface="Calibri (MS) Bold"/>
-                <a:sym typeface="Calibri (MS) Bold"/>
-              </a:rPr>
-              <a:t>SISTEMAS DE DISCO</a:t>
-            </a:r>
-          </a:p>
-          <a:p>
-            <a:pPr algn="l">
-              <a:lnSpc>
-                <a:spcPts val="4323"/>
-              </a:lnSpc>
-            </a:pPr>
-            <a:r>
-              <a:rPr lang="en-US" sz="3602" b="true">
-                <a:solidFill>
-                  <a:srgbClr val="F8FAFC"/>
-                </a:solidFill>
-                <a:latin typeface="Calibri (MS) Bold"/>
-                <a:ea typeface="Calibri (MS) Bold"/>
-                <a:cs typeface="Calibri (MS) Bold"/>
-                <a:sym typeface="Calibri (MS) Bold"/>
-              </a:rPr>
-              <a:t>Exercício 3 – Parâmetros Físicos e Desempenho</a:t>
+                <a:spcPts val="2760"/>
+              </a:lnSpc>
+              <a:spcBef>
+                <a:spcPct val="0"/>
+              </a:spcBef>
+            </a:pPr>
+            <a:r>
+              <a:rPr lang="en-US" sz="2300">
+                <a:solidFill>
+                  <a:srgbClr val="FFFFFF"/>
+                </a:solidFill>
+                <a:latin typeface="Calibri (MS)"/>
+                <a:ea typeface="Calibri (MS)"/>
+                <a:cs typeface="Calibri (MS)"/>
+                <a:sym typeface="Calibri (MS)"/>
+              </a:rPr>
+              <a:t>sudo pacman -Syu --needed fio git python python-pip libjpeg-turbo</a:t>
+            </a:r>
+          </a:p>
+          <a:p>
+            <a:pPr algn="l">
+              <a:lnSpc>
+                <a:spcPts val="2760"/>
+              </a:lnSpc>
+              <a:spcBef>
+                <a:spcPct val="0"/>
+              </a:spcBef>
+            </a:pPr>
+          </a:p>
+          <a:p>
+            <a:pPr algn="l">
+              <a:lnSpc>
+                <a:spcPts val="2760"/>
+              </a:lnSpc>
+              <a:spcBef>
+                <a:spcPct val="0"/>
+              </a:spcBef>
+            </a:pPr>
+            <a:r>
+              <a:rPr lang="en-US" sz="2300">
+                <a:solidFill>
+                  <a:srgbClr val="FFFFFF"/>
+                </a:solidFill>
+                <a:latin typeface="Calibri (MS)"/>
+                <a:ea typeface="Calibri (MS)"/>
+                <a:cs typeface="Calibri (MS)"/>
+                <a:sym typeface="Calibri (MS)"/>
+              </a:rPr>
+              <a:t>cd ~</a:t>
+            </a:r>
+          </a:p>
+          <a:p>
+            <a:pPr algn="l">
+              <a:lnSpc>
+                <a:spcPts val="2760"/>
+              </a:lnSpc>
+              <a:spcBef>
+                <a:spcPct val="0"/>
+              </a:spcBef>
+            </a:pPr>
+            <a:r>
+              <a:rPr lang="en-US" sz="2300">
+                <a:solidFill>
+                  <a:srgbClr val="FFFFFF"/>
+                </a:solidFill>
+                <a:latin typeface="Calibri (MS)"/>
+                <a:ea typeface="Calibri (MS)"/>
+                <a:cs typeface="Calibri (MS)"/>
+                <a:sym typeface="Calibri (MS)"/>
+              </a:rPr>
+              <a:t>rm -rf fio-plot</a:t>
+            </a:r>
+          </a:p>
+          <a:p>
+            <a:pPr algn="l">
+              <a:lnSpc>
+                <a:spcPts val="2760"/>
+              </a:lnSpc>
+              <a:spcBef>
+                <a:spcPct val="0"/>
+              </a:spcBef>
+            </a:pPr>
+            <a:r>
+              <a:rPr lang="en-US" sz="2300">
+                <a:solidFill>
+                  <a:srgbClr val="FFFFFF"/>
+                </a:solidFill>
+                <a:latin typeface="Calibri (MS)"/>
+                <a:ea typeface="Calibri (MS)"/>
+                <a:cs typeface="Calibri (MS)"/>
+                <a:sym typeface="Calibri (MS)"/>
+              </a:rPr>
+              <a:t>git clone https://github.com/louwrentius/fio-plot.git</a:t>
+            </a:r>
+          </a:p>
+          <a:p>
+            <a:pPr algn="l">
+              <a:lnSpc>
+                <a:spcPts val="2760"/>
+              </a:lnSpc>
+              <a:spcBef>
+                <a:spcPct val="0"/>
+              </a:spcBef>
+            </a:pPr>
+            <a:r>
+              <a:rPr lang="en-US" sz="2300">
+                <a:solidFill>
+                  <a:srgbClr val="FFFFFF"/>
+                </a:solidFill>
+                <a:latin typeface="Calibri (MS)"/>
+                <a:ea typeface="Calibri (MS)"/>
+                <a:cs typeface="Calibri (MS)"/>
+                <a:sym typeface="Calibri (MS)"/>
+              </a:rPr>
+              <a:t>cd fio-plot</a:t>
+            </a:r>
+          </a:p>
+          <a:p>
+            <a:pPr algn="l">
+              <a:lnSpc>
+                <a:spcPts val="2760"/>
+              </a:lnSpc>
+              <a:spcBef>
+                <a:spcPct val="0"/>
+              </a:spcBef>
+            </a:pPr>
+          </a:p>
+          <a:p>
+            <a:pPr algn="l">
+              <a:lnSpc>
+                <a:spcPts val="2760"/>
+              </a:lnSpc>
+              <a:spcBef>
+                <a:spcPct val="0"/>
+              </a:spcBef>
+            </a:pPr>
+            <a:r>
+              <a:rPr lang="en-US" sz="2300">
+                <a:solidFill>
+                  <a:srgbClr val="FFFFFF"/>
+                </a:solidFill>
+                <a:latin typeface="Calibri (MS)"/>
+                <a:ea typeface="Calibri (MS)"/>
+                <a:cs typeface="Calibri (MS)"/>
+                <a:sym typeface="Calibri (MS)"/>
+              </a:rPr>
+              <a:t>python -m venv venv</a:t>
+            </a:r>
+          </a:p>
+          <a:p>
+            <a:pPr algn="l">
+              <a:lnSpc>
+                <a:spcPts val="2760"/>
+              </a:lnSpc>
+              <a:spcBef>
+                <a:spcPct val="0"/>
+              </a:spcBef>
+            </a:pPr>
+            <a:r>
+              <a:rPr lang="en-US" sz="2300">
+                <a:solidFill>
+                  <a:srgbClr val="FFFFFF"/>
+                </a:solidFill>
+                <a:latin typeface="Calibri (MS)"/>
+                <a:ea typeface="Calibri (MS)"/>
+                <a:cs typeface="Calibri (MS)"/>
+                <a:sym typeface="Calibri (MS)"/>
+              </a:rPr>
+              <a:t>source venv/bin/activate.fish</a:t>
+            </a:r>
+          </a:p>
+          <a:p>
+            <a:pPr algn="l">
+              <a:lnSpc>
+                <a:spcPts val="2760"/>
+              </a:lnSpc>
+              <a:spcBef>
+                <a:spcPct val="0"/>
+              </a:spcBef>
+            </a:pPr>
+            <a:r>
+              <a:rPr lang="en-US" sz="2300">
+                <a:solidFill>
+                  <a:srgbClr val="FFFFFF"/>
+                </a:solidFill>
+                <a:latin typeface="Calibri (MS)"/>
+                <a:ea typeface="Calibri (MS)"/>
+                <a:cs typeface="Calibri (MS)"/>
+                <a:sym typeface="Calibri (MS)"/>
+              </a:rPr>
+              <a:t>pip install fio-plot</a:t>
+            </a:r>
+          </a:p>
+          <a:p>
+            <a:pPr algn="l">
+              <a:lnSpc>
+                <a:spcPts val="2760"/>
+              </a:lnSpc>
+              <a:spcBef>
+                <a:spcPct val="0"/>
+              </a:spcBef>
+            </a:pPr>
+            <a:r>
+              <a:rPr lang="en-US" sz="2300">
+                <a:solidFill>
+                  <a:srgbClr val="FFFFFF"/>
+                </a:solidFill>
+                <a:latin typeface="Calibri (MS)"/>
+                <a:ea typeface="Calibri (MS)"/>
+                <a:cs typeface="Calibri (MS)"/>
+                <a:sym typeface="Calibri (MS)"/>
+              </a:rPr>
+              <a:t>mkdir -p ~/temp</a:t>
+            </a:r>
+          </a:p>
+          <a:p>
+            <a:pPr algn="l">
+              <a:lnSpc>
+                <a:spcPts val="2760"/>
+              </a:lnSpc>
+              <a:spcBef>
+                <a:spcPct val="0"/>
+              </a:spcBef>
+            </a:pPr>
+          </a:p>
+          <a:p>
+            <a:pPr algn="l">
+              <a:lnSpc>
+                <a:spcPts val="2760"/>
+              </a:lnSpc>
+              <a:spcBef>
+                <a:spcPct val="0"/>
+              </a:spcBef>
+            </a:pPr>
+            <a:r>
+              <a:rPr lang="en-US" sz="2300">
+                <a:solidFill>
+                  <a:srgbClr val="FFFFFF"/>
+                </a:solidFill>
+                <a:latin typeface="Calibri (MS)"/>
+                <a:ea typeface="Calibri (MS)"/>
+                <a:cs typeface="Calibri (MS)"/>
+                <a:sym typeface="Calibri (MS)"/>
+              </a:rPr>
+              <a:t>bench-fio --target ~/temp --type directory --size 2G --mode randread --output MeuPC --iodepth 1 8 32 --numjobs 1 4</a:t>
+            </a:r>
+          </a:p>
+          <a:p>
+            <a:pPr algn="l">
+              <a:lnSpc>
+                <a:spcPts val="2760"/>
+              </a:lnSpc>
+              <a:spcBef>
+                <a:spcPct val="0"/>
+              </a:spcBef>
+            </a:pPr>
+            <a:r>
+              <a:rPr lang="en-US" sz="2300">
+                <a:solidFill>
+                  <a:srgbClr val="FFFFFF"/>
+                </a:solidFill>
+                <a:latin typeface="Calibri (MS)"/>
+                <a:ea typeface="Calibri (MS)"/>
+                <a:cs typeface="Calibri (MS)"/>
+                <a:sym typeface="Calibri (MS)"/>
+              </a:rPr>
+              <a:t>fio-plot -i MeuPC/temp/4k/ -T "Performance de Leitura - Kingston SNV2S" -l -r randread -d 1 8 32 -n 1</a:t>
+            </a:r>
+          </a:p>
+          <a:p>
+            <a:pPr algn="l">
+              <a:lnSpc>
+                <a:spcPts val="2760"/>
+              </a:lnSpc>
+              <a:spcBef>
+                <a:spcPct val="0"/>
+              </a:spcBef>
+            </a:pPr>
+            <a:r>
+              <a:rPr lang="en-US" sz="2300">
+                <a:solidFill>
+                  <a:srgbClr val="FFFFFF"/>
+                </a:solidFill>
+                <a:latin typeface="Calibri (MS)"/>
+                <a:ea typeface="Calibri (MS)"/>
+                <a:cs typeface="Calibri (MS)"/>
+                <a:sym typeface="Calibri (MS)"/>
+              </a:rPr>
+              <a:t>fio-plot -i MeuPC/temp/4k/ -T "IOPS vs Latencia (Agrupado) - Kingston SNV2S" -l -r randread -d 1 8 32 -n 1 --group-bars</a:t>
+            </a:r>
+          </a:p>
+          <a:p>
+            <a:pPr algn="l">
+              <a:lnSpc>
+                <a:spcPts val="2760"/>
+              </a:lnSpc>
+              <a:spcBef>
+                <a:spcPct val="0"/>
+              </a:spcBef>
+            </a:pPr>
+            <a:r>
+              <a:rPr lang="en-US" sz="2300">
+                <a:solidFill>
+                  <a:srgbClr val="FFFFFF"/>
+                </a:solidFill>
+                <a:latin typeface="Calibri (MS)"/>
+                <a:ea typeface="Calibri (MS)"/>
+                <a:cs typeface="Calibri (MS)"/>
+                <a:sym typeface="Calibri (MS)"/>
+              </a:rPr>
+              <a:t>fio-plot -i MeuPC/temp/4k/ -T "Latencia 3D - Kingston SNV2S" -L -t lat -r randread -d 1 8 32 -n 1 4</a:t>
+            </a:r>
+          </a:p>
+          <a:p>
+            <a:pPr algn="l">
+              <a:lnSpc>
+                <a:spcPts val="2760"/>
+              </a:lnSpc>
+              <a:spcBef>
+                <a:spcPct val="0"/>
+              </a:spcBef>
+            </a:pPr>
+            <a:r>
+              <a:rPr lang="en-US" sz="2300">
+                <a:solidFill>
+                  <a:srgbClr val="FFFFFF"/>
+                </a:solidFill>
+                <a:latin typeface="Calibri (MS)"/>
+                <a:ea typeface="Calibri (MS)"/>
+                <a:cs typeface="Calibri (MS)"/>
+                <a:sym typeface="Calibri (MS)"/>
+              </a:rPr>
+              <a:t>xdg-open .</a:t>
             </a:r>
           </a:p>
         </p:txBody>
@@ -5072,8 +5579,8 @@
         </p:nvSpPr>
         <p:spPr>
           <a:xfrm rot="0">
-            <a:off x="1189577" y="2194369"/>
-            <a:ext cx="15877384" cy="6819548"/>
+            <a:off x="1189577" y="566214"/>
+            <a:ext cx="15877384" cy="819150"/>
           </a:xfrm>
           <a:prstGeom prst="rect">
             <a:avLst/>
@@ -5087,18 +5594,11 @@
           <a:p>
             <a:pPr algn="l">
               <a:lnSpc>
-                <a:spcPts val="2521"/>
-              </a:lnSpc>
-            </a:pPr>
-          </a:p>
-          <a:p>
-            <a:pPr algn="l">
-              <a:lnSpc>
-                <a:spcPts val="2521"/>
-              </a:lnSpc>
-            </a:pPr>
-            <a:r>
-              <a:rPr lang="en-US" sz="2101" b="true">
+                <a:spcPts val="1981"/>
+              </a:lnSpc>
+            </a:pPr>
+            <a:r>
+              <a:rPr lang="en-US" sz="1651" b="true">
                 <a:solidFill>
                   <a:srgbClr val="06B6D4"/>
                 </a:solidFill>
@@ -5107,264 +5607,26 @@
                 <a:cs typeface="Calibri (MS) Bold"/>
                 <a:sym typeface="Calibri (MS) Bold"/>
               </a:rPr>
-              <a:t>a) Capacidade do disco:</a:t>
-            </a:r>
-            <a:r>
-              <a:rPr lang="en-US" sz="2101">
+              <a:t>CÓDIGO FONTE</a:t>
+            </a:r>
+          </a:p>
+          <a:p>
+            <a:pPr algn="l">
+              <a:lnSpc>
+                <a:spcPts val="4323"/>
+              </a:lnSpc>
+            </a:pPr>
+            <a:r>
+              <a:rPr lang="en-US" sz="3602" b="true">
                 <a:solidFill>
                   <a:srgbClr val="F8FAFC"/>
-                </a:solidFill>
-                <a:latin typeface="Calibri (MS)"/>
-                <a:ea typeface="Calibri (MS)"/>
-                <a:cs typeface="Calibri (MS)"/>
-                <a:sym typeface="Calibri (MS)"/>
-              </a:rPr>
-              <a:t> 8 superfícies × 512 trilhas × 64 setores × 1 kB = 262.144 kB = 256 MB.</a:t>
-            </a:r>
-          </a:p>
-          <a:p>
-            <a:pPr algn="l">
-              <a:lnSpc>
-                <a:spcPts val="2521"/>
-              </a:lnSpc>
-            </a:pPr>
-            <a:r>
-              <a:rPr lang="en-US" sz="2101" b="true">
-                <a:solidFill>
-                  <a:srgbClr val="06B6D4"/>
                 </a:solidFill>
                 <a:latin typeface="Calibri (MS) Bold"/>
                 <a:ea typeface="Calibri (MS) Bold"/>
                 <a:cs typeface="Calibri (MS) Bold"/>
                 <a:sym typeface="Calibri (MS) Bold"/>
               </a:rPr>
-              <a:t>b) Tempo médio de acesso (tA):</a:t>
-            </a:r>
-            <a:r>
-              <a:rPr lang="en-US" sz="2101">
-                <a:solidFill>
-                  <a:srgbClr val="F8FAFC"/>
-                </a:solidFill>
-                <a:latin typeface="Calibri (MS)"/>
-                <a:ea typeface="Calibri (MS)"/>
-                <a:cs typeface="Calibri (MS)"/>
-                <a:sym typeface="Calibri (MS)"/>
-              </a:rPr>
-              <a:t> </a:t>
-            </a:r>
-          </a:p>
-          <a:p>
-            <a:pPr algn="l">
-              <a:lnSpc>
-                <a:spcPts val="2521"/>
-              </a:lnSpc>
-            </a:pPr>
-            <a:r>
-              <a:rPr lang="en-US" sz="2101">
-                <a:solidFill>
-                  <a:srgbClr val="F8FAFC"/>
-                </a:solidFill>
-                <a:latin typeface="Calibri (MS)"/>
-                <a:ea typeface="Calibri (MS)"/>
-                <a:cs typeface="Calibri (MS)"/>
-                <a:sym typeface="Calibri (MS)"/>
-              </a:rPr>
-              <a:t>• Seek: 8 ms</a:t>
-            </a:r>
-          </a:p>
-          <a:p>
-            <a:pPr algn="l">
-              <a:lnSpc>
-                <a:spcPts val="2521"/>
-              </a:lnSpc>
-            </a:pPr>
-            <a:r>
-              <a:rPr lang="en-US" sz="2101">
-                <a:solidFill>
-                  <a:srgbClr val="F8FAFC"/>
-                </a:solidFill>
-                <a:latin typeface="Calibri (MS)"/>
-                <a:ea typeface="Calibri (MS)"/>
-                <a:cs typeface="Calibri (MS)"/>
-                <a:sym typeface="Calibri (MS)"/>
-              </a:rPr>
-              <a:t>• Rotacional: 0.5 × (60 / 3600) s = 8.33 ms</a:t>
-            </a:r>
-          </a:p>
-          <a:p>
-            <a:pPr algn="l">
-              <a:lnSpc>
-                <a:spcPts val="2521"/>
-              </a:lnSpc>
-            </a:pPr>
-            <a:r>
-              <a:rPr lang="en-US" sz="2101">
-                <a:solidFill>
-                  <a:srgbClr val="F8FAFC"/>
-                </a:solidFill>
-                <a:latin typeface="Calibri (MS)"/>
-                <a:ea typeface="Calibri (MS)"/>
-                <a:cs typeface="Calibri (MS)"/>
-                <a:sym typeface="Calibri (MS)"/>
-              </a:rPr>
-              <a:t>• Transferência: (1 / 64) × (1 / 60) s = 0.26 ms</a:t>
-            </a:r>
-          </a:p>
-          <a:p>
-            <a:pPr algn="l">
-              <a:lnSpc>
-                <a:spcPts val="2521"/>
-              </a:lnSpc>
-            </a:pPr>
-            <a:r>
-              <a:rPr lang="en-US" sz="2101">
-                <a:solidFill>
-                  <a:srgbClr val="F8FAFC"/>
-                </a:solidFill>
-                <a:latin typeface="Calibri (MS)"/>
-                <a:ea typeface="Calibri (MS)"/>
-                <a:cs typeface="Calibri (MS)"/>
-                <a:sym typeface="Calibri (MS)"/>
-              </a:rPr>
-              <a:t>Total tA = 8 + 8.33 + 0.26 = 16.59 ms</a:t>
-            </a:r>
-          </a:p>
-          <a:p>
-            <a:pPr algn="l">
-              <a:lnSpc>
-                <a:spcPts val="2521"/>
-              </a:lnSpc>
-            </a:pPr>
-            <a:r>
-              <a:rPr lang="en-US" sz="2101" b="true">
-                <a:solidFill>
-                  <a:srgbClr val="06B6D4"/>
-                </a:solidFill>
-                <a:latin typeface="Calibri (MS) Bold"/>
-                <a:ea typeface="Calibri (MS) Bold"/>
-                <a:cs typeface="Calibri (MS) Bold"/>
-                <a:sym typeface="Calibri (MS) Bold"/>
-              </a:rPr>
-              <a:t>c) Tempo para transferir arquivo de 5-MB:</a:t>
-            </a:r>
-            <a:r>
-              <a:rPr lang="en-US" sz="2101">
-                <a:solidFill>
-                  <a:srgbClr val="F8FAFC"/>
-                </a:solidFill>
-                <a:latin typeface="Calibri (MS)"/>
-                <a:ea typeface="Calibri (MS)"/>
-                <a:cs typeface="Calibri (MS)"/>
-                <a:sym typeface="Calibri (MS)"/>
-              </a:rPr>
-              <a:t> 5MB = 5120 setores. Isso requer ler 10 cilindros completos (10 × 512 setores).</a:t>
-            </a:r>
-          </a:p>
-          <a:p>
-            <a:pPr algn="l">
-              <a:lnSpc>
-                <a:spcPts val="2521"/>
-              </a:lnSpc>
-            </a:pPr>
-            <a:r>
-              <a:rPr lang="en-US" sz="2101">
-                <a:solidFill>
-                  <a:srgbClr val="F8FAFC"/>
-                </a:solidFill>
-                <a:latin typeface="Calibri (MS)"/>
-                <a:ea typeface="Calibri (MS)"/>
-                <a:cs typeface="Calibri (MS)"/>
-                <a:sym typeface="Calibri (MS)"/>
-              </a:rPr>
-              <a:t>• 1º Acesso: 16.33 ms (seek + rotacional)</a:t>
-            </a:r>
-          </a:p>
-          <a:p>
-            <a:pPr algn="l">
-              <a:lnSpc>
-                <a:spcPts val="2521"/>
-              </a:lnSpc>
-            </a:pPr>
-            <a:r>
-              <a:rPr lang="en-US" sz="2101">
-                <a:solidFill>
-                  <a:srgbClr val="F8FAFC"/>
-                </a:solidFill>
-                <a:latin typeface="Calibri (MS)"/>
-                <a:ea typeface="Calibri (MS)"/>
-                <a:cs typeface="Calibri (MS)"/>
-                <a:sym typeface="Calibri (MS)"/>
-              </a:rPr>
-              <a:t>• Ler 10 cilindros: 10 × (8 trilhas × 16.67 ms) = 1333.33 ms</a:t>
-            </a:r>
-          </a:p>
-          <a:p>
-            <a:pPr algn="l">
-              <a:lnSpc>
-                <a:spcPts val="2521"/>
-              </a:lnSpc>
-            </a:pPr>
-            <a:r>
-              <a:rPr lang="en-US" sz="2101">
-                <a:solidFill>
-                  <a:srgbClr val="F8FAFC"/>
-                </a:solidFill>
-                <a:latin typeface="Calibri (MS)"/>
-                <a:ea typeface="Calibri (MS)"/>
-                <a:cs typeface="Calibri (MS)"/>
-                <a:sym typeface="Calibri (MS)"/>
-              </a:rPr>
-              <a:t>• Mudança de cilindro (9 pulos): 9 × 1.5 ms = 13.5 ms</a:t>
-            </a:r>
-          </a:p>
-          <a:p>
-            <a:pPr algn="l">
-              <a:lnSpc>
-                <a:spcPts val="2521"/>
-              </a:lnSpc>
-            </a:pPr>
-            <a:r>
-              <a:rPr lang="en-US" sz="2101">
-                <a:solidFill>
-                  <a:srgbClr val="F8FAFC"/>
-                </a:solidFill>
-                <a:latin typeface="Calibri (MS)"/>
-                <a:ea typeface="Calibri (MS)"/>
-                <a:cs typeface="Calibri (MS)"/>
-                <a:sym typeface="Calibri (MS)"/>
-              </a:rPr>
-              <a:t>Total = 16.33 + 1333.33 + 13.5 = 1363.16 ms (~1.36 segundos).</a:t>
-            </a:r>
-          </a:p>
-          <a:p>
-            <a:pPr algn="l">
-              <a:lnSpc>
-                <a:spcPts val="2521"/>
-              </a:lnSpc>
-            </a:pPr>
-            <a:r>
-              <a:rPr lang="en-US" sz="2101" b="true">
-                <a:solidFill>
-                  <a:srgbClr val="06B6D4"/>
-                </a:solidFill>
-                <a:latin typeface="Calibri (MS) Bold"/>
-                <a:ea typeface="Calibri (MS) Bold"/>
-                <a:cs typeface="Calibri (MS) Bold"/>
-                <a:sym typeface="Calibri (MS) Bold"/>
-              </a:rPr>
-              <a:t>d) Taxa de transferência de rajada:</a:t>
-            </a:r>
-            <a:r>
-              <a:rPr lang="en-US" sz="2101">
-                <a:solidFill>
-                  <a:srgbClr val="F8FAFC"/>
-                </a:solidFill>
-                <a:latin typeface="Calibri (MS)"/>
-                <a:ea typeface="Calibri (MS)"/>
-                <a:cs typeface="Calibri (MS)"/>
-                <a:sym typeface="Calibri (MS)"/>
-              </a:rPr>
-              <a:t> 1 trilha (64 kB) lida em 1 rotação (16.67 ms). Rate = 64 kB / 0.01667 s = 3.84 MB/s.</a:t>
+              <a:t>Código utilizado no CachyOs</a:t>
             </a:r>
           </a:p>
         </p:txBody>
@@ -5378,7 +5640,7 @@
 </file>
 
 <file path=ppt/slides/slide9.xml><?xml version="1.0" encoding="utf-8"?>
-<p:sld xmlns:p="http://schemas.openxmlformats.org/presentationml/2006/main" xmlns:a="http://schemas.openxmlformats.org/drawingml/2006/main">
+<p:sld xmlns:p="http://schemas.openxmlformats.org/presentationml/2006/main" xmlns:a="http://schemas.openxmlformats.org/drawingml/2006/main" xmlns:r="http://schemas.openxmlformats.org/officeDocument/2006/relationships">
   <p:cSld>
     <p:bg>
       <p:bgPr>
@@ -5409,8 +5671,8 @@
         </p:nvSpPr>
         <p:spPr>
           <a:xfrm rot="0">
-            <a:off x="1189577" y="566214"/>
-            <a:ext cx="15877384" cy="1309811"/>
+            <a:off x="884041" y="1247861"/>
+            <a:ext cx="23431339" cy="915531"/>
           </a:xfrm>
           <a:prstGeom prst="rect">
             <a:avLst/>
@@ -5424,39 +5686,20 @@
           <a:p>
             <a:pPr algn="l">
               <a:lnSpc>
-                <a:spcPts val="1981"/>
-              </a:lnSpc>
-            </a:pPr>
-            <a:r>
-              <a:rPr lang="en-US" sz="1651" b="true">
-                <a:solidFill>
-                  <a:srgbClr val="06B6D4"/>
+                <a:spcPts val="6380"/>
+              </a:lnSpc>
+            </a:pPr>
+            <a:r>
+              <a:rPr lang="en-US" sz="5316" b="true">
+                <a:solidFill>
+                  <a:srgbClr val="F8FAFC"/>
                 </a:solidFill>
                 <a:latin typeface="Calibri (MS) Bold"/>
                 <a:ea typeface="Calibri (MS) Bold"/>
                 <a:cs typeface="Calibri (MS) Bold"/>
                 <a:sym typeface="Calibri (MS) Bold"/>
               </a:rPr>
-              <a:t>SISTEMAS DE DISCO</a:t>
-            </a:r>
-          </a:p>
-          <a:p>
-            <a:pPr algn="l">
-              <a:lnSpc>
-                <a:spcPts val="4323"/>
-              </a:lnSpc>
-            </a:pPr>
-            <a:r>
-              <a:rPr lang="en-US" sz="3602" b="true">
-                <a:solidFill>
-                  <a:srgbClr val="F8FAFC"/>
-                </a:solidFill>
-                <a:latin typeface="Calibri (MS) Bold"/>
-                <a:ea typeface="Calibri (MS) Bold"/>
-                <a:cs typeface="Calibri (MS) Bold"/>
-                <a:sym typeface="Calibri (MS) Bold"/>
-              </a:rPr>
-              <a:t>Exercício 4 – Disco com Prato Único</a:t>
+              <a:t>Referencias:</a:t>
             </a:r>
           </a:p>
         </p:txBody>
@@ -5469,8 +5712,8 @@
         </p:nvSpPr>
         <p:spPr>
           <a:xfrm rot="0">
-            <a:off x="1189577" y="2194369"/>
-            <a:ext cx="15877384" cy="6819548"/>
+            <a:off x="1390704" y="3131648"/>
+            <a:ext cx="16326485" cy="4855210"/>
           </a:xfrm>
           <a:prstGeom prst="rect">
             <a:avLst/>
@@ -5484,239 +5727,81 @@
           <a:p>
             <a:pPr algn="l">
               <a:lnSpc>
-                <a:spcPts val="2521"/>
-              </a:lnSpc>
-            </a:pPr>
-          </a:p>
-          <a:p>
-            <a:pPr algn="l">
-              <a:lnSpc>
-                <a:spcPts val="2521"/>
-              </a:lnSpc>
-            </a:pPr>
-            <a:r>
-              <a:rPr lang="en-US" sz="2101" b="true">
-                <a:solidFill>
-                  <a:srgbClr val="06B6D4"/>
-                </a:solidFill>
-                <a:latin typeface="Calibri (MS) Bold"/>
-                <a:ea typeface="Calibri (MS) Bold"/>
-                <a:cs typeface="Calibri (MS) Bold"/>
-                <a:sym typeface="Calibri (MS) Bold"/>
-              </a:rPr>
-              <a:t>Parâmetros iniciais:</a:t>
-            </a:r>
-            <a:r>
-              <a:rPr lang="en-US" sz="2101">
-                <a:solidFill>
-                  <a:srgbClr val="F8FAFC"/>
-                </a:solidFill>
-                <a:latin typeface="Calibri (MS)"/>
-                <a:ea typeface="Calibri (MS)"/>
-                <a:cs typeface="Calibri (MS)"/>
-                <a:sym typeface="Calibri (MS)"/>
-              </a:rPr>
-              <a:t> 7200 rpm (120 rev/s), 30.000 trilhas, 600 setores/trilha. Cabeça inicia na trilha 0.</a:t>
-            </a:r>
-          </a:p>
-          <a:p>
-            <a:pPr algn="l">
-              <a:lnSpc>
-                <a:spcPts val="2521"/>
-              </a:lnSpc>
-            </a:pPr>
-            <a:r>
-              <a:rPr lang="en-US" sz="2101" b="true">
-                <a:solidFill>
-                  <a:srgbClr val="06B6D4"/>
-                </a:solidFill>
-                <a:latin typeface="Calibri (MS) Bold"/>
-                <a:ea typeface="Calibri (MS) Bold"/>
-                <a:cs typeface="Calibri (MS) Bold"/>
-                <a:sym typeface="Calibri (MS) Bold"/>
-              </a:rPr>
-              <a:t>a) Qual é o tempo médio de seek?</a:t>
-            </a:r>
-            <a:r>
-              <a:rPr lang="en-US" sz="2101">
-                <a:solidFill>
-                  <a:srgbClr val="F8FAFC"/>
-                </a:solidFill>
-                <a:latin typeface="Calibri (MS)"/>
-                <a:ea typeface="Calibri (MS)"/>
-                <a:cs typeface="Calibri (MS)"/>
-                <a:sym typeface="Calibri (MS)"/>
-              </a:rPr>
-              <a:t> A distância média partindo da borda (trilha 0) para um ponto aleatório é metade das trilhas = 15.000 trilhas. </a:t>
-            </a:r>
-          </a:p>
-          <a:p>
-            <a:pPr algn="l">
-              <a:lnSpc>
-                <a:spcPts val="2521"/>
-              </a:lnSpc>
-            </a:pPr>
-            <a:r>
-              <a:rPr lang="en-US" sz="2101">
-                <a:solidFill>
-                  <a:srgbClr val="F8FAFC"/>
-                </a:solidFill>
-                <a:latin typeface="Calibri (MS)"/>
-                <a:ea typeface="Calibri (MS)"/>
-                <a:cs typeface="Calibri (MS)"/>
-                <a:sym typeface="Calibri (MS)"/>
-              </a:rPr>
-              <a:t>Tempo = (15.000 / 100) × 1 ms = 150 ms.</a:t>
-            </a:r>
-          </a:p>
-          <a:p>
-            <a:pPr algn="l">
-              <a:lnSpc>
-                <a:spcPts val="2521"/>
-              </a:lnSpc>
-            </a:pPr>
-            <a:r>
-              <a:rPr lang="en-US" sz="2101" b="true">
-                <a:solidFill>
-                  <a:srgbClr val="06B6D4"/>
-                </a:solidFill>
-                <a:latin typeface="Calibri (MS) Bold"/>
-                <a:ea typeface="Calibri (MS) Bold"/>
-                <a:cs typeface="Calibri (MS) Bold"/>
-                <a:sym typeface="Calibri (MS) Bold"/>
-              </a:rPr>
-              <a:t>b) Qual é a latência rotacional média?</a:t>
-            </a:r>
-            <a:r>
-              <a:rPr lang="en-US" sz="2101">
-                <a:solidFill>
-                  <a:srgbClr val="F8FAFC"/>
-                </a:solidFill>
-                <a:latin typeface="Calibri (MS)"/>
-                <a:ea typeface="Calibri (MS)"/>
-                <a:cs typeface="Calibri (MS)"/>
-                <a:sym typeface="Calibri (MS)"/>
-              </a:rPr>
-              <a:t> É o tempo de meia rotação do disco. </a:t>
-            </a:r>
-          </a:p>
-          <a:p>
-            <a:pPr algn="l">
-              <a:lnSpc>
-                <a:spcPts val="2521"/>
-              </a:lnSpc>
-            </a:pPr>
-            <a:r>
-              <a:rPr lang="en-US" sz="2101">
-                <a:solidFill>
-                  <a:srgbClr val="F8FAFC"/>
-                </a:solidFill>
-                <a:latin typeface="Calibri (MS)"/>
-                <a:ea typeface="Calibri (MS)"/>
-                <a:cs typeface="Calibri (MS)"/>
-                <a:sym typeface="Calibri (MS)"/>
-              </a:rPr>
-              <a:t>Tempo = 0.5 × (1 / 120 rev/s) = 4.17 ms.</a:t>
-            </a:r>
-          </a:p>
-          <a:p>
-            <a:pPr algn="l">
-              <a:lnSpc>
-                <a:spcPts val="2521"/>
-              </a:lnSpc>
-            </a:pPr>
-            <a:r>
-              <a:rPr lang="en-US" sz="2101" b="true">
-                <a:solidFill>
-                  <a:srgbClr val="06B6D4"/>
-                </a:solidFill>
-                <a:latin typeface="Calibri (MS) Bold"/>
-                <a:ea typeface="Calibri (MS) Bold"/>
-                <a:cs typeface="Calibri (MS) Bold"/>
-                <a:sym typeface="Calibri (MS) Bold"/>
-              </a:rPr>
-              <a:t>c) Qual é o tempo de transferência por setor?</a:t>
-            </a:r>
-            <a:r>
-              <a:rPr lang="en-US" sz="2101">
-                <a:solidFill>
-                  <a:srgbClr val="F8FAFC"/>
-                </a:solidFill>
-                <a:latin typeface="Calibri (MS)"/>
-                <a:ea typeface="Calibri (MS)"/>
-                <a:cs typeface="Calibri (MS)"/>
-                <a:sym typeface="Calibri (MS)"/>
-              </a:rPr>
-              <a:t> É o tempo de uma rotação inteira dividido pela quantidade de setores na trilha. </a:t>
-            </a:r>
-          </a:p>
-          <a:p>
-            <a:pPr algn="l">
-              <a:lnSpc>
-                <a:spcPts val="2521"/>
-              </a:lnSpc>
-            </a:pPr>
-            <a:r>
-              <a:rPr lang="en-US" sz="2101">
-                <a:solidFill>
-                  <a:srgbClr val="F8FAFC"/>
-                </a:solidFill>
-                <a:latin typeface="Calibri (MS)"/>
-                <a:ea typeface="Calibri (MS)"/>
-                <a:cs typeface="Calibri (MS)"/>
-                <a:sym typeface="Calibri (MS)"/>
-              </a:rPr>
-              <a:t>Tempo = (1 / 120) / 600 = 0.0138 ms.</a:t>
-            </a:r>
-          </a:p>
-          <a:p>
-            <a:pPr algn="l">
-              <a:lnSpc>
-                <a:spcPts val="2521"/>
-              </a:lnSpc>
-            </a:pPr>
-            <a:r>
-              <a:rPr lang="en-US" sz="2101" b="true">
-                <a:solidFill>
-                  <a:srgbClr val="06B6D4"/>
-                </a:solidFill>
-                <a:latin typeface="Calibri (MS) Bold"/>
-                <a:ea typeface="Calibri (MS) Bold"/>
-                <a:cs typeface="Calibri (MS) Bold"/>
-                <a:sym typeface="Calibri (MS) Bold"/>
-              </a:rPr>
-              <a:t>d) Média de tempo total para a requisição:</a:t>
-            </a:r>
-            <a:r>
-              <a:rPr lang="en-US" sz="2101">
-                <a:solidFill>
-                  <a:srgbClr val="F8FAFC"/>
-                </a:solidFill>
-                <a:latin typeface="Calibri (MS)"/>
-                <a:ea typeface="Calibri (MS)"/>
-                <a:cs typeface="Calibri (MS)"/>
-                <a:sym typeface="Calibri (MS)"/>
-              </a:rPr>
-              <a:t> Soma de todos os atrasos (Seek + Rotacional + Transferência). </a:t>
-            </a:r>
-          </a:p>
-          <a:p>
-            <a:pPr algn="l">
-              <a:lnSpc>
-                <a:spcPts val="2521"/>
-              </a:lnSpc>
-            </a:pPr>
-            <a:r>
-              <a:rPr lang="en-US" sz="2101">
-                <a:solidFill>
-                  <a:srgbClr val="F8FAFC"/>
-                </a:solidFill>
-                <a:latin typeface="Calibri (MS)"/>
-                <a:ea typeface="Calibri (MS)"/>
-                <a:cs typeface="Calibri (MS)"/>
-                <a:sym typeface="Calibri (MS)"/>
-              </a:rPr>
-              <a:t>Total = 150 + 4.17 + 0.0138 = 154.18 ms.</a:t>
+                <a:spcPts val="6439"/>
+              </a:lnSpc>
+            </a:pPr>
+            <a:r>
+              <a:rPr lang="en-US" sz="4599" u="sng">
+                <a:solidFill>
+                  <a:srgbClr val="FFFFFF"/>
+                </a:solidFill>
+                <a:latin typeface="Arimo"/>
+                <a:ea typeface="Arimo"/>
+                <a:cs typeface="Arimo"/>
+                <a:sym typeface="Arimo"/>
+                <a:hlinkClick r:id="rId2" tooltip="https://pypi.org/project/fio-plot/https:/github.com/louwrentius/fio-plot/blob/master/README.md"/>
+              </a:rPr>
+              <a:t>https://pypi.org/project/fio-plot/</a:t>
+            </a:r>
+          </a:p>
+          <a:p>
+            <a:pPr algn="l">
+              <a:lnSpc>
+                <a:spcPts val="6439"/>
+              </a:lnSpc>
+            </a:pPr>
+          </a:p>
+          <a:p>
+            <a:pPr algn="l">
+              <a:lnSpc>
+                <a:spcPts val="6439"/>
+              </a:lnSpc>
+            </a:pPr>
+          </a:p>
+          <a:p>
+            <a:pPr algn="l">
+              <a:lnSpc>
+                <a:spcPts val="6439"/>
+              </a:lnSpc>
+            </a:pPr>
+            <a:r>
+              <a:rPr lang="en-US" sz="4599" u="sng">
+                <a:solidFill>
+                  <a:srgbClr val="FFFFFF"/>
+                </a:solidFill>
+                <a:latin typeface="Arimo"/>
+                <a:ea typeface="Arimo"/>
+                <a:cs typeface="Arimo"/>
+                <a:sym typeface="Arimo"/>
+                <a:hlinkClick r:id="rId3" tooltip="https://pypi.org/project/fio-plot/https:/github.com/louwrentius/fio-plot/blob/master/README.md"/>
+              </a:rPr>
+              <a:t>https:/github.com/louwrentius/fio-plot/blob/master/README.md</a:t>
+            </a:r>
+          </a:p>
+          <a:p>
+            <a:pPr algn="l">
+              <a:lnSpc>
+                <a:spcPts val="6439"/>
+              </a:lnSpc>
+            </a:pPr>
+          </a:p>
+          <a:p>
+            <a:pPr algn="l">
+              <a:lnSpc>
+                <a:spcPts val="6439"/>
+              </a:lnSpc>
+            </a:pPr>
+            <a:r>
+              <a:rPr lang="en-US" sz="4599" u="sng">
+                <a:solidFill>
+                  <a:srgbClr val="FFFFFF"/>
+                </a:solidFill>
+                <a:latin typeface="Arimo"/>
+                <a:ea typeface="Arimo"/>
+                <a:cs typeface="Arimo"/>
+                <a:sym typeface="Arimo"/>
+              </a:rPr>
+              <a:t>https://github.com/Jr-Lopes/trabalhoORI</a:t>
             </a:r>
           </a:p>
         </p:txBody>

</xml_diff>